<commit_message>
updated abstract and PPT for presentation
</commit_message>
<xml_diff>
--- a/SalesGPTPresentation.pptx
+++ b/SalesGPTPresentation.pptx
@@ -320,7 +320,7 @@
           <a:p>
             <a:fld id="{F2940E26-1BFB-4BC3-A471-4350E1CC52C5}" type="datetimeFigureOut">
               <a:rPr lang="en-US" smtClean="0"/>
-              <a:t>3/18/2026</a:t>
+              <a:t>4/11/2026</a:t>
             </a:fld>
             <a:endParaRPr lang="en-US"/>
           </a:p>
@@ -488,7 +488,7 @@
           <a:p>
             <a:fld id="{F2940E26-1BFB-4BC3-A471-4350E1CC52C5}" type="datetimeFigureOut">
               <a:rPr lang="en-US" smtClean="0"/>
-              <a:t>3/18/2026</a:t>
+              <a:t>4/11/2026</a:t>
             </a:fld>
             <a:endParaRPr lang="en-US"/>
           </a:p>
@@ -666,7 +666,7 @@
           <a:p>
             <a:fld id="{F2940E26-1BFB-4BC3-A471-4350E1CC52C5}" type="datetimeFigureOut">
               <a:rPr lang="en-US" smtClean="0"/>
-              <a:t>3/18/2026</a:t>
+              <a:t>4/11/2026</a:t>
             </a:fld>
             <a:endParaRPr lang="en-US"/>
           </a:p>
@@ -834,7 +834,7 @@
           <a:p>
             <a:fld id="{F2940E26-1BFB-4BC3-A471-4350E1CC52C5}" type="datetimeFigureOut">
               <a:rPr lang="en-US" smtClean="0"/>
-              <a:t>3/18/2026</a:t>
+              <a:t>4/11/2026</a:t>
             </a:fld>
             <a:endParaRPr lang="en-US"/>
           </a:p>
@@ -1079,7 +1079,7 @@
           <a:p>
             <a:fld id="{F2940E26-1BFB-4BC3-A471-4350E1CC52C5}" type="datetimeFigureOut">
               <a:rPr lang="en-US" smtClean="0"/>
-              <a:t>3/18/2026</a:t>
+              <a:t>4/11/2026</a:t>
             </a:fld>
             <a:endParaRPr lang="en-US"/>
           </a:p>
@@ -1364,7 +1364,7 @@
           <a:p>
             <a:fld id="{F2940E26-1BFB-4BC3-A471-4350E1CC52C5}" type="datetimeFigureOut">
               <a:rPr lang="en-US" smtClean="0"/>
-              <a:t>3/18/2026</a:t>
+              <a:t>4/11/2026</a:t>
             </a:fld>
             <a:endParaRPr lang="en-US"/>
           </a:p>
@@ -1783,7 +1783,7 @@
           <a:p>
             <a:fld id="{F2940E26-1BFB-4BC3-A471-4350E1CC52C5}" type="datetimeFigureOut">
               <a:rPr lang="en-US" smtClean="0"/>
-              <a:t>3/18/2026</a:t>
+              <a:t>4/11/2026</a:t>
             </a:fld>
             <a:endParaRPr lang="en-US"/>
           </a:p>
@@ -1900,7 +1900,7 @@
           <a:p>
             <a:fld id="{F2940E26-1BFB-4BC3-A471-4350E1CC52C5}" type="datetimeFigureOut">
               <a:rPr lang="en-US" smtClean="0"/>
-              <a:t>3/18/2026</a:t>
+              <a:t>4/11/2026</a:t>
             </a:fld>
             <a:endParaRPr lang="en-US"/>
           </a:p>
@@ -1995,7 +1995,7 @@
           <a:p>
             <a:fld id="{F2940E26-1BFB-4BC3-A471-4350E1CC52C5}" type="datetimeFigureOut">
               <a:rPr lang="en-US" smtClean="0"/>
-              <a:t>3/18/2026</a:t>
+              <a:t>4/11/2026</a:t>
             </a:fld>
             <a:endParaRPr lang="en-US"/>
           </a:p>
@@ -2270,7 +2270,7 @@
           <a:p>
             <a:fld id="{F2940E26-1BFB-4BC3-A471-4350E1CC52C5}" type="datetimeFigureOut">
               <a:rPr lang="en-US" smtClean="0"/>
-              <a:t>3/18/2026</a:t>
+              <a:t>4/11/2026</a:t>
             </a:fld>
             <a:endParaRPr lang="en-US"/>
           </a:p>
@@ -2522,7 +2522,7 @@
           <a:p>
             <a:fld id="{F2940E26-1BFB-4BC3-A471-4350E1CC52C5}" type="datetimeFigureOut">
               <a:rPr lang="en-US" smtClean="0"/>
-              <a:t>3/18/2026</a:t>
+              <a:t>4/11/2026</a:t>
             </a:fld>
             <a:endParaRPr lang="en-US"/>
           </a:p>
@@ -2733,7 +2733,7 @@
           <a:p>
             <a:fld id="{F2940E26-1BFB-4BC3-A471-4350E1CC52C5}" type="datetimeFigureOut">
               <a:rPr lang="en-US" smtClean="0"/>
-              <a:t>3/18/2026</a:t>
+              <a:t>4/11/2026</a:t>
             </a:fld>
             <a:endParaRPr lang="en-US"/>
           </a:p>
@@ -7776,6 +7776,12 @@
 <file path=ppt/slides/slide7.xml><?xml version="1.0" encoding="utf-8"?>
 <p:sld xmlns:a="http://schemas.openxmlformats.org/drawingml/2006/main" xmlns:r="http://schemas.openxmlformats.org/officeDocument/2006/relationships" xmlns:p="http://schemas.openxmlformats.org/presentationml/2006/main">
   <p:cSld>
+    <p:bg>
+      <p:bgPr>
+        <a:noFill/>
+        <a:effectLst/>
+      </p:bgPr>
+    </p:bg>
     <p:spTree>
       <p:nvGrpSpPr>
         <p:cNvPr id="1" name=""/>
@@ -7863,139 +7869,772 @@
           </a:p>
         </p:txBody>
       </p:sp>
-      <p:sp>
-        <p:nvSpPr>
-          <p:cNvPr id="5" name="TextBox 4">
+      <p:graphicFrame>
+        <p:nvGraphicFramePr>
+          <p:cNvPr id="2" name="Table 1">
             <a:extLst>
               <a:ext uri="{FF2B5EF4-FFF2-40B4-BE49-F238E27FC236}">
-                <a16:creationId xmlns:a16="http://schemas.microsoft.com/office/drawing/2014/main" id="{EE93B2E5-E88D-41C2-9C27-6DEE5D5EBF3B}"/>
+                <a16:creationId xmlns:a16="http://schemas.microsoft.com/office/drawing/2014/main" id="{15C5E590-C5B4-4148-870E-4DB0238BDB5E}"/>
               </a:ext>
             </a:extLst>
           </p:cNvPr>
-          <p:cNvSpPr txBox="1"/>
-          <p:nvPr/>
-        </p:nvSpPr>
-        <p:spPr>
-          <a:xfrm>
-            <a:off x="800100" y="1066800"/>
-            <a:ext cx="7543800" cy="5078313"/>
-          </a:xfrm>
-          <a:prstGeom prst="rect">
-            <a:avLst/>
-          </a:prstGeom>
-          <a:noFill/>
-        </p:spPr>
-        <p:txBody>
-          <a:bodyPr wrap="square">
-            <a:spAutoFit/>
-          </a:bodyPr>
-          <a:lstStyle/>
-          <a:p>
-            <a:r>
-              <a:rPr lang="en-US" b="1" dirty="0"/>
-              <a:t>1. Retrieval-Augmented Generation (RAG)</a:t>
-            </a:r>
-            <a:endParaRPr lang="en-US" dirty="0"/>
-          </a:p>
-          <a:p>
-            <a:pPr>
-              <a:buFont typeface="Arial" panose="020B0604020202020204" pitchFamily="34" charset="0"/>
-              <a:buChar char="•"/>
-            </a:pPr>
-            <a:r>
-              <a:rPr lang="en-US" b="1" dirty="0"/>
-              <a:t>Lewis et al. (2020):</a:t>
-            </a:r>
-            <a:r>
-              <a:rPr lang="en-US" dirty="0"/>
-              <a:t> Established RAG as the industry standard for grounding LLM responses in proprietary data to mitigate hallucinations. However, their work and subsequent tools (e.g., </a:t>
-            </a:r>
-            <a:r>
-              <a:rPr lang="en-US" dirty="0" err="1"/>
-              <a:t>LangChain</a:t>
-            </a:r>
-            <a:r>
-              <a:rPr lang="en-US" dirty="0"/>
-              <a:t>) primarily focus on synchronous information retrieval, lacking autonomous background reasoning.</a:t>
-            </a:r>
-          </a:p>
-          <a:p>
-            <a:r>
-              <a:rPr lang="en-US" b="1" dirty="0"/>
-              <a:t>2. LLM-Based Agents and Conversational Systems</a:t>
-            </a:r>
-            <a:endParaRPr lang="en-US" dirty="0"/>
-          </a:p>
-          <a:p>
-            <a:pPr>
-              <a:buFont typeface="Arial" panose="020B0604020202020204" pitchFamily="34" charset="0"/>
-              <a:buChar char="•"/>
-            </a:pPr>
-            <a:r>
-              <a:rPr lang="en-US" b="1" dirty="0"/>
-              <a:t>Xi et al. (2024):</a:t>
-            </a:r>
-            <a:r>
-              <a:rPr lang="en-US" dirty="0"/>
-              <a:t> Surveyed the potential of autonomous agents, highlighting a critical gap in applying structured business frameworks (like BANT) directly to raw conversational data without human intervention.</a:t>
-            </a:r>
-          </a:p>
-          <a:p>
-            <a:r>
-              <a:rPr lang="en-US" b="1" dirty="0"/>
-              <a:t>3. Inference Latency and Instruction Tuning</a:t>
-            </a:r>
-            <a:endParaRPr lang="en-US" dirty="0"/>
-          </a:p>
-          <a:p>
-            <a:pPr>
-              <a:buFont typeface="Arial" panose="020B0604020202020204" pitchFamily="34" charset="0"/>
-              <a:buChar char="•"/>
-            </a:pPr>
-            <a:r>
-              <a:rPr lang="en-US" b="1" dirty="0"/>
-              <a:t>Peng et al. (2023) &amp; </a:t>
-            </a:r>
-            <a:r>
-              <a:rPr lang="en-US" b="1" dirty="0" err="1"/>
-              <a:t>Bubeck</a:t>
-            </a:r>
-            <a:r>
-              <a:rPr lang="en-US" b="1" dirty="0"/>
-              <a:t> et al. (2023):</a:t>
-            </a:r>
-            <a:r>
-              <a:rPr lang="en-US" dirty="0"/>
-              <a:t> Demonstrated that forcing single-layer LLMs to execute complex reasoning simultaneously with dialogue generation drastically increases inference latency, degrading real-time user experience.</a:t>
-            </a:r>
-          </a:p>
-          <a:p>
-            <a:r>
-              <a:rPr lang="en-US" b="1" dirty="0"/>
-              <a:t>4. Sales Automation and Lead Scoring</a:t>
-            </a:r>
-            <a:endParaRPr lang="en-US" dirty="0"/>
-          </a:p>
-          <a:p>
-            <a:pPr>
-              <a:buFont typeface="Arial" panose="020B0604020202020204" pitchFamily="34" charset="0"/>
-              <a:buChar char="•"/>
-            </a:pPr>
-            <a:r>
-              <a:rPr lang="en-US" b="1" dirty="0" err="1"/>
-              <a:t>Syam</a:t>
-            </a:r>
-            <a:r>
-              <a:rPr lang="en-US" b="1" dirty="0"/>
-              <a:t> and Sharma (2018):</a:t>
-            </a:r>
-            <a:r>
-              <a:rPr lang="en-US" dirty="0"/>
-              <a:t> Noted that traditional automated lead scoring heavily relies on rigid heuristics (such as website clicks or email opens) and historical data, rather than deep semantic analysis of live conversational intent.</a:t>
-            </a:r>
-          </a:p>
-        </p:txBody>
-      </p:sp>
+          <p:cNvGraphicFramePr>
+            <a:graphicFrameLocks noGrp="1"/>
+          </p:cNvGraphicFramePr>
+          <p:nvPr>
+            <p:extLst>
+              <p:ext uri="{D42A27DB-BD31-4B8C-83A1-F6EECF244321}">
+                <p14:modId xmlns:p14="http://schemas.microsoft.com/office/powerpoint/2010/main" val="857007336"/>
+              </p:ext>
+            </p:extLst>
+          </p:nvPr>
+        </p:nvGraphicFramePr>
+        <p:xfrm>
+          <a:off x="609601" y="1066800"/>
+          <a:ext cx="8077199" cy="4918712"/>
+        </p:xfrm>
+        <a:graphic>
+          <a:graphicData uri="http://schemas.openxmlformats.org/drawingml/2006/table">
+            <a:tbl>
+              <a:tblPr>
+                <a:tableStyleId>{5C22544A-7EE6-4342-B048-85BDC9FD1C3A}</a:tableStyleId>
+              </a:tblPr>
+              <a:tblGrid>
+                <a:gridCol w="1293948">
+                  <a:extLst>
+                    <a:ext uri="{9D8B030D-6E8A-4147-A177-3AD203B41FA5}">
+                      <a16:colId xmlns:a16="http://schemas.microsoft.com/office/drawing/2014/main" val="4277242781"/>
+                    </a:ext>
+                  </a:extLst>
+                </a:gridCol>
+                <a:gridCol w="1293948">
+                  <a:extLst>
+                    <a:ext uri="{9D8B030D-6E8A-4147-A177-3AD203B41FA5}">
+                      <a16:colId xmlns:a16="http://schemas.microsoft.com/office/drawing/2014/main" val="450470322"/>
+                    </a:ext>
+                  </a:extLst>
+                </a:gridCol>
+                <a:gridCol w="1293948">
+                  <a:extLst>
+                    <a:ext uri="{9D8B030D-6E8A-4147-A177-3AD203B41FA5}">
+                      <a16:colId xmlns:a16="http://schemas.microsoft.com/office/drawing/2014/main" val="2036249135"/>
+                    </a:ext>
+                  </a:extLst>
+                </a:gridCol>
+                <a:gridCol w="1293948">
+                  <a:extLst>
+                    <a:ext uri="{9D8B030D-6E8A-4147-A177-3AD203B41FA5}">
+                      <a16:colId xmlns:a16="http://schemas.microsoft.com/office/drawing/2014/main" val="2022657305"/>
+                    </a:ext>
+                  </a:extLst>
+                </a:gridCol>
+                <a:gridCol w="1293948">
+                  <a:extLst>
+                    <a:ext uri="{9D8B030D-6E8A-4147-A177-3AD203B41FA5}">
+                      <a16:colId xmlns:a16="http://schemas.microsoft.com/office/drawing/2014/main" val="1467397748"/>
+                    </a:ext>
+                  </a:extLst>
+                </a:gridCol>
+                <a:gridCol w="1607459">
+                  <a:extLst>
+                    <a:ext uri="{9D8B030D-6E8A-4147-A177-3AD203B41FA5}">
+                      <a16:colId xmlns:a16="http://schemas.microsoft.com/office/drawing/2014/main" val="2509542044"/>
+                    </a:ext>
+                  </a:extLst>
+                </a:gridCol>
+              </a:tblGrid>
+              <a:tr h="148805">
+                <a:tc>
+                  <a:txBody>
+                    <a:bodyPr/>
+                    <a:lstStyle/>
+                    <a:p>
+                      <a:pPr rtl="0"/>
+                      <a:r>
+                        <a:rPr lang="en-IN" sz="1200" b="1" dirty="0" err="1">
+                          <a:solidFill>
+                            <a:srgbClr val="1F1F1F"/>
+                          </a:solidFill>
+                          <a:effectLst/>
+                        </a:rPr>
+                        <a:t>S.No</a:t>
+                      </a:r>
+                      <a:endParaRPr lang="en-IN" sz="1200" dirty="0">
+                        <a:solidFill>
+                          <a:srgbClr val="1F1F1F"/>
+                        </a:solidFill>
+                        <a:effectLst/>
+                        <a:latin typeface="Google Sans Text"/>
+                      </a:endParaRPr>
+                    </a:p>
+                  </a:txBody>
+                  <a:tcPr marL="15360" marR="15360" marT="20479" marB="20479" anchor="ctr"/>
+                </a:tc>
+                <a:tc>
+                  <a:txBody>
+                    <a:bodyPr/>
+                    <a:lstStyle/>
+                    <a:p>
+                      <a:pPr rtl="0"/>
+                      <a:r>
+                        <a:rPr lang="en-IN" sz="1200" b="1" dirty="0">
+                          <a:solidFill>
+                            <a:srgbClr val="1F1F1F"/>
+                          </a:solidFill>
+                          <a:effectLst/>
+                        </a:rPr>
+                        <a:t>Author(s)</a:t>
+                      </a:r>
+                      <a:endParaRPr lang="en-IN" sz="1200" dirty="0">
+                        <a:solidFill>
+                          <a:srgbClr val="1F1F1F"/>
+                        </a:solidFill>
+                        <a:effectLst/>
+                        <a:latin typeface="Google Sans Text"/>
+                      </a:endParaRPr>
+                    </a:p>
+                  </a:txBody>
+                  <a:tcPr marL="15360" marR="15360" marT="20479" marB="20479" anchor="ctr"/>
+                </a:tc>
+                <a:tc>
+                  <a:txBody>
+                    <a:bodyPr/>
+                    <a:lstStyle/>
+                    <a:p>
+                      <a:pPr rtl="0"/>
+                      <a:r>
+                        <a:rPr lang="en-IN" sz="1200" b="1">
+                          <a:solidFill>
+                            <a:srgbClr val="1F1F1F"/>
+                          </a:solidFill>
+                          <a:effectLst/>
+                        </a:rPr>
+                        <a:t>Reference</a:t>
+                      </a:r>
+                      <a:endParaRPr lang="en-IN" sz="1200">
+                        <a:solidFill>
+                          <a:srgbClr val="1F1F1F"/>
+                        </a:solidFill>
+                        <a:effectLst/>
+                        <a:latin typeface="Google Sans Text"/>
+                      </a:endParaRPr>
+                    </a:p>
+                  </a:txBody>
+                  <a:tcPr marL="15360" marR="15360" marT="20479" marB="20479" anchor="ctr"/>
+                </a:tc>
+                <a:tc>
+                  <a:txBody>
+                    <a:bodyPr/>
+                    <a:lstStyle/>
+                    <a:p>
+                      <a:pPr rtl="0"/>
+                      <a:r>
+                        <a:rPr lang="en-IN" sz="1200" b="1">
+                          <a:solidFill>
+                            <a:srgbClr val="1F1F1F"/>
+                          </a:solidFill>
+                          <a:effectLst/>
+                        </a:rPr>
+                        <a:t>Tools &amp; Techniques</a:t>
+                      </a:r>
+                      <a:endParaRPr lang="en-IN" sz="1200">
+                        <a:solidFill>
+                          <a:srgbClr val="1F1F1F"/>
+                        </a:solidFill>
+                        <a:effectLst/>
+                        <a:latin typeface="Google Sans Text"/>
+                      </a:endParaRPr>
+                    </a:p>
+                  </a:txBody>
+                  <a:tcPr marL="15360" marR="15360" marT="20479" marB="20479" anchor="ctr"/>
+                </a:tc>
+                <a:tc>
+                  <a:txBody>
+                    <a:bodyPr/>
+                    <a:lstStyle/>
+                    <a:p>
+                      <a:pPr rtl="0"/>
+                      <a:r>
+                        <a:rPr lang="en-IN" sz="1200" b="1">
+                          <a:solidFill>
+                            <a:srgbClr val="1F1F1F"/>
+                          </a:solidFill>
+                          <a:effectLst/>
+                        </a:rPr>
+                        <a:t>Results</a:t>
+                      </a:r>
+                      <a:endParaRPr lang="en-IN" sz="1200">
+                        <a:solidFill>
+                          <a:srgbClr val="1F1F1F"/>
+                        </a:solidFill>
+                        <a:effectLst/>
+                        <a:latin typeface="Google Sans Text"/>
+                      </a:endParaRPr>
+                    </a:p>
+                  </a:txBody>
+                  <a:tcPr marL="15360" marR="15360" marT="20479" marB="20479" anchor="ctr"/>
+                </a:tc>
+                <a:tc>
+                  <a:txBody>
+                    <a:bodyPr/>
+                    <a:lstStyle/>
+                    <a:p>
+                      <a:pPr rtl="0"/>
+                      <a:r>
+                        <a:rPr lang="en-IN" sz="1200" b="1">
+                          <a:solidFill>
+                            <a:srgbClr val="1F1F1F"/>
+                          </a:solidFill>
+                          <a:effectLst/>
+                        </a:rPr>
+                        <a:t>Limitations</a:t>
+                      </a:r>
+                      <a:endParaRPr lang="en-IN" sz="1200">
+                        <a:solidFill>
+                          <a:srgbClr val="1F1F1F"/>
+                        </a:solidFill>
+                        <a:effectLst/>
+                        <a:latin typeface="Google Sans Text"/>
+                      </a:endParaRPr>
+                    </a:p>
+                  </a:txBody>
+                  <a:tcPr marL="15360" marR="15360" marT="20479" marB="20479" anchor="ctr"/>
+                </a:tc>
+                <a:extLst>
+                  <a:ext uri="{0D108BD9-81ED-4DB2-BD59-A6C34878D82A}">
+                    <a16:rowId xmlns:a16="http://schemas.microsoft.com/office/drawing/2014/main" val="2311223292"/>
+                  </a:ext>
+                </a:extLst>
+              </a:tr>
+              <a:tr h="715407">
+                <a:tc>
+                  <a:txBody>
+                    <a:bodyPr/>
+                    <a:lstStyle/>
+                    <a:p>
+                      <a:pPr rtl="0"/>
+                      <a:r>
+                        <a:rPr lang="en-IN" sz="1200" b="1">
+                          <a:solidFill>
+                            <a:srgbClr val="1F1F1F"/>
+                          </a:solidFill>
+                          <a:effectLst/>
+                        </a:rPr>
+                        <a:t>1</a:t>
+                      </a:r>
+                      <a:endParaRPr lang="en-IN" sz="1200">
+                        <a:solidFill>
+                          <a:srgbClr val="1F1F1F"/>
+                        </a:solidFill>
+                        <a:effectLst/>
+                        <a:latin typeface="Google Sans Text"/>
+                      </a:endParaRPr>
+                    </a:p>
+                  </a:txBody>
+                  <a:tcPr marL="15360" marR="15360" marT="20479" marB="20479" anchor="ctr"/>
+                </a:tc>
+                <a:tc>
+                  <a:txBody>
+                    <a:bodyPr/>
+                    <a:lstStyle/>
+                    <a:p>
+                      <a:pPr rtl="0"/>
+                      <a:r>
+                        <a:rPr lang="en-IN" sz="1200">
+                          <a:solidFill>
+                            <a:srgbClr val="1F1F1F"/>
+                          </a:solidFill>
+                          <a:effectLst/>
+                        </a:rPr>
+                        <a:t>Lewis, P., et al.</a:t>
+                      </a:r>
+                      <a:endParaRPr lang="en-IN" sz="1200">
+                        <a:solidFill>
+                          <a:srgbClr val="1F1F1F"/>
+                        </a:solidFill>
+                        <a:effectLst/>
+                        <a:latin typeface="Google Sans Text"/>
+                      </a:endParaRPr>
+                    </a:p>
+                  </a:txBody>
+                  <a:tcPr marL="15360" marR="15360" marT="20479" marB="20479" anchor="ctr"/>
+                </a:tc>
+                <a:tc>
+                  <a:txBody>
+                    <a:bodyPr/>
+                    <a:lstStyle/>
+                    <a:p>
+                      <a:pPr rtl="0"/>
+                      <a:endParaRPr lang="en-US" sz="1200">
+                        <a:solidFill>
+                          <a:srgbClr val="1F1F1F"/>
+                        </a:solidFill>
+                        <a:effectLst/>
+                      </a:endParaRPr>
+                    </a:p>
+                    <a:p>
+                      <a:pPr rtl="0"/>
+                      <a:r>
+                        <a:rPr lang="en-US" sz="1200">
+                          <a:solidFill>
+                            <a:srgbClr val="1F1F1F"/>
+                          </a:solidFill>
+                          <a:effectLst/>
+                        </a:rPr>
+                        <a:t>Retrieval-Augmented Generation for Knowledge-Intensive NLP Tasks (NeurIPS, 2020) </a:t>
+                      </a:r>
+                      <a:endParaRPr lang="en-US" sz="1200">
+                        <a:solidFill>
+                          <a:srgbClr val="1F1F1F"/>
+                        </a:solidFill>
+                        <a:effectLst/>
+                        <a:latin typeface="Google Sans Text"/>
+                      </a:endParaRPr>
+                    </a:p>
+                  </a:txBody>
+                  <a:tcPr marL="15360" marR="15360" marT="20479" marB="20479" anchor="ctr"/>
+                </a:tc>
+                <a:tc>
+                  <a:txBody>
+                    <a:bodyPr/>
+                    <a:lstStyle/>
+                    <a:p>
+                      <a:pPr rtl="0"/>
+                      <a:r>
+                        <a:rPr lang="en-IN" sz="1200">
+                          <a:solidFill>
+                            <a:srgbClr val="1F1F1F"/>
+                          </a:solidFill>
+                          <a:effectLst/>
+                        </a:rPr>
+                        <a:t>Pre-trained sequence-to-sequence models; Dense Passage Retrieval (DPR); Vector databases. </a:t>
+                      </a:r>
+                      <a:endParaRPr lang="en-IN" sz="1200">
+                        <a:solidFill>
+                          <a:srgbClr val="1F1F1F"/>
+                        </a:solidFill>
+                        <a:effectLst/>
+                        <a:latin typeface="Google Sans Text"/>
+                      </a:endParaRPr>
+                    </a:p>
+                  </a:txBody>
+                  <a:tcPr marL="15360" marR="15360" marT="20479" marB="20479" anchor="ctr"/>
+                </a:tc>
+                <a:tc>
+                  <a:txBody>
+                    <a:bodyPr/>
+                    <a:lstStyle/>
+                    <a:p>
+                      <a:pPr rtl="0"/>
+                      <a:r>
+                        <a:rPr lang="en-US" sz="1200">
+                          <a:solidFill>
+                            <a:srgbClr val="1F1F1F"/>
+                          </a:solidFill>
+                          <a:effectLst/>
+                        </a:rPr>
+                        <a:t>Established RAG as highly effective for reducing hallucination and grounding LLM responses in factual, proprietary data. </a:t>
+                      </a:r>
+                      <a:endParaRPr lang="en-US" sz="1200">
+                        <a:solidFill>
+                          <a:srgbClr val="1F1F1F"/>
+                        </a:solidFill>
+                        <a:effectLst/>
+                        <a:latin typeface="Google Sans Text"/>
+                      </a:endParaRPr>
+                    </a:p>
+                  </a:txBody>
+                  <a:tcPr marL="15360" marR="15360" marT="20479" marB="20479" anchor="ctr"/>
+                </a:tc>
+                <a:tc>
+                  <a:txBody>
+                    <a:bodyPr/>
+                    <a:lstStyle/>
+                    <a:p>
+                      <a:pPr rtl="0"/>
+                      <a:r>
+                        <a:rPr lang="en-US" sz="1200">
+                          <a:solidFill>
+                            <a:srgbClr val="1F1F1F"/>
+                          </a:solidFill>
+                          <a:effectLst/>
+                        </a:rPr>
+                        <a:t>Focuses heavily on synchronous information retrieval; lacks autonomous background reasoning or multi-step agentic workflows.</a:t>
+                      </a:r>
+                      <a:endParaRPr lang="en-US" sz="1200">
+                        <a:solidFill>
+                          <a:srgbClr val="1F1F1F"/>
+                        </a:solidFill>
+                        <a:effectLst/>
+                        <a:latin typeface="Google Sans Text"/>
+                      </a:endParaRPr>
+                    </a:p>
+                  </a:txBody>
+                  <a:tcPr marL="15360" marR="15360" marT="20479" marB="20479" anchor="ctr"/>
+                </a:tc>
+                <a:extLst>
+                  <a:ext uri="{0D108BD9-81ED-4DB2-BD59-A6C34878D82A}">
+                    <a16:rowId xmlns:a16="http://schemas.microsoft.com/office/drawing/2014/main" val="321279384"/>
+                  </a:ext>
+                </a:extLst>
+              </a:tr>
+              <a:tr h="818426">
+                <a:tc>
+                  <a:txBody>
+                    <a:bodyPr/>
+                    <a:lstStyle/>
+                    <a:p>
+                      <a:pPr rtl="0"/>
+                      <a:r>
+                        <a:rPr lang="en-IN" sz="1200" b="1">
+                          <a:solidFill>
+                            <a:srgbClr val="1F1F1F"/>
+                          </a:solidFill>
+                          <a:effectLst/>
+                        </a:rPr>
+                        <a:t>2</a:t>
+                      </a:r>
+                      <a:endParaRPr lang="en-IN" sz="1200">
+                        <a:solidFill>
+                          <a:srgbClr val="1F1F1F"/>
+                        </a:solidFill>
+                        <a:effectLst/>
+                        <a:latin typeface="Google Sans Text"/>
+                      </a:endParaRPr>
+                    </a:p>
+                  </a:txBody>
+                  <a:tcPr marL="15360" marR="15360" marT="20479" marB="20479" anchor="ctr"/>
+                </a:tc>
+                <a:tc>
+                  <a:txBody>
+                    <a:bodyPr/>
+                    <a:lstStyle/>
+                    <a:p>
+                      <a:pPr rtl="0"/>
+                      <a:r>
+                        <a:rPr lang="en-IN" sz="1200">
+                          <a:solidFill>
+                            <a:srgbClr val="1F1F1F"/>
+                          </a:solidFill>
+                          <a:effectLst/>
+                        </a:rPr>
+                        <a:t>Xi, Z., et al.</a:t>
+                      </a:r>
+                      <a:endParaRPr lang="en-IN" sz="1200">
+                        <a:solidFill>
+                          <a:srgbClr val="1F1F1F"/>
+                        </a:solidFill>
+                        <a:effectLst/>
+                        <a:latin typeface="Google Sans Text"/>
+                      </a:endParaRPr>
+                    </a:p>
+                  </a:txBody>
+                  <a:tcPr marL="15360" marR="15360" marT="20479" marB="20479" anchor="ctr"/>
+                </a:tc>
+                <a:tc>
+                  <a:txBody>
+                    <a:bodyPr/>
+                    <a:lstStyle/>
+                    <a:p>
+                      <a:pPr rtl="0"/>
+                      <a:endParaRPr lang="en-US" sz="1200">
+                        <a:solidFill>
+                          <a:srgbClr val="1F1F1F"/>
+                        </a:solidFill>
+                        <a:effectLst/>
+                      </a:endParaRPr>
+                    </a:p>
+                    <a:p>
+                      <a:pPr rtl="0"/>
+                      <a:r>
+                        <a:rPr lang="en-US" sz="1200">
+                          <a:solidFill>
+                            <a:srgbClr val="1F1F1F"/>
+                          </a:solidFill>
+                          <a:effectLst/>
+                        </a:rPr>
+                        <a:t>The Rise and Potential of Large Language Model Based Agents: A Survey (Frontiers of Computer Science, 2024) </a:t>
+                      </a:r>
+                      <a:endParaRPr lang="en-US" sz="1200">
+                        <a:solidFill>
+                          <a:srgbClr val="1F1F1F"/>
+                        </a:solidFill>
+                        <a:effectLst/>
+                        <a:latin typeface="Google Sans Text"/>
+                      </a:endParaRPr>
+                    </a:p>
+                  </a:txBody>
+                  <a:tcPr marL="15360" marR="15360" marT="20479" marB="20479" anchor="ctr"/>
+                </a:tc>
+                <a:tc>
+                  <a:txBody>
+                    <a:bodyPr/>
+                    <a:lstStyle/>
+                    <a:p>
+                      <a:pPr rtl="0"/>
+                      <a:r>
+                        <a:rPr lang="en-US" sz="1200">
+                          <a:solidFill>
+                            <a:srgbClr val="1F1F1F"/>
+                          </a:solidFill>
+                          <a:effectLst/>
+                        </a:rPr>
+                        <a:t>LLM-based autonomous agents; Prompt engineering; Task decomposition; Memory management. </a:t>
+                      </a:r>
+                      <a:endParaRPr lang="en-US" sz="1200">
+                        <a:solidFill>
+                          <a:srgbClr val="1F1F1F"/>
+                        </a:solidFill>
+                        <a:effectLst/>
+                        <a:latin typeface="Google Sans Text"/>
+                      </a:endParaRPr>
+                    </a:p>
+                  </a:txBody>
+                  <a:tcPr marL="15360" marR="15360" marT="20479" marB="20479" anchor="ctr"/>
+                </a:tc>
+                <a:tc>
+                  <a:txBody>
+                    <a:bodyPr/>
+                    <a:lstStyle/>
+                    <a:p>
+                      <a:pPr rtl="0"/>
+                      <a:r>
+                        <a:rPr lang="en-US" sz="1200">
+                          <a:solidFill>
+                            <a:srgbClr val="1F1F1F"/>
+                          </a:solidFill>
+                          <a:effectLst/>
+                        </a:rPr>
+                        <a:t>Demonstrated that LLMs can act as autonomous agents capable of planning, tool use, and executing complex, multi-step workflows. </a:t>
+                      </a:r>
+                      <a:endParaRPr lang="en-US" sz="1200">
+                        <a:solidFill>
+                          <a:srgbClr val="1F1F1F"/>
+                        </a:solidFill>
+                        <a:effectLst/>
+                        <a:latin typeface="Google Sans Text"/>
+                      </a:endParaRPr>
+                    </a:p>
+                  </a:txBody>
+                  <a:tcPr marL="15360" marR="15360" marT="20479" marB="20479" anchor="ctr"/>
+                </a:tc>
+                <a:tc>
+                  <a:txBody>
+                    <a:bodyPr/>
+                    <a:lstStyle/>
+                    <a:p>
+                      <a:pPr rtl="0"/>
+                      <a:r>
+                        <a:rPr lang="en-US" sz="1200">
+                          <a:solidFill>
+                            <a:srgbClr val="1F1F1F"/>
+                          </a:solidFill>
+                          <a:effectLst/>
+                        </a:rPr>
+                        <a:t>Highlights a critical gap in applying structured business frameworks (like BANT) directly to raw conversational data without human intervention.</a:t>
+                      </a:r>
+                      <a:endParaRPr lang="en-US" sz="1200">
+                        <a:solidFill>
+                          <a:srgbClr val="1F1F1F"/>
+                        </a:solidFill>
+                        <a:effectLst/>
+                        <a:latin typeface="Google Sans Text"/>
+                      </a:endParaRPr>
+                    </a:p>
+                  </a:txBody>
+                  <a:tcPr marL="15360" marR="15360" marT="20479" marB="20479" anchor="ctr"/>
+                </a:tc>
+                <a:extLst>
+                  <a:ext uri="{0D108BD9-81ED-4DB2-BD59-A6C34878D82A}">
+                    <a16:rowId xmlns:a16="http://schemas.microsoft.com/office/drawing/2014/main" val="692316997"/>
+                  </a:ext>
+                </a:extLst>
+              </a:tr>
+              <a:tr h="818426">
+                <a:tc>
+                  <a:txBody>
+                    <a:bodyPr/>
+                    <a:lstStyle/>
+                    <a:p>
+                      <a:pPr rtl="0"/>
+                      <a:r>
+                        <a:rPr lang="en-IN" sz="1200" b="1">
+                          <a:solidFill>
+                            <a:srgbClr val="1F1F1F"/>
+                          </a:solidFill>
+                          <a:effectLst/>
+                        </a:rPr>
+                        <a:t>3</a:t>
+                      </a:r>
+                      <a:endParaRPr lang="en-IN" sz="1200">
+                        <a:solidFill>
+                          <a:srgbClr val="1F1F1F"/>
+                        </a:solidFill>
+                        <a:effectLst/>
+                        <a:latin typeface="Google Sans Text"/>
+                      </a:endParaRPr>
+                    </a:p>
+                  </a:txBody>
+                  <a:tcPr marL="15360" marR="15360" marT="20479" marB="20479" anchor="ctr"/>
+                </a:tc>
+                <a:tc>
+                  <a:txBody>
+                    <a:bodyPr/>
+                    <a:lstStyle/>
+                    <a:p>
+                      <a:pPr rtl="0"/>
+                      <a:r>
+                        <a:rPr lang="en-IN" sz="1200" dirty="0">
+                          <a:solidFill>
+                            <a:srgbClr val="1F1F1F"/>
+                          </a:solidFill>
+                          <a:effectLst/>
+                        </a:rPr>
+                        <a:t>Peng, B., et al. &amp; </a:t>
+                      </a:r>
+                      <a:r>
+                        <a:rPr lang="en-IN" sz="1200" dirty="0" err="1">
+                          <a:solidFill>
+                            <a:srgbClr val="1F1F1F"/>
+                          </a:solidFill>
+                          <a:effectLst/>
+                        </a:rPr>
+                        <a:t>Bubeck</a:t>
+                      </a:r>
+                      <a:r>
+                        <a:rPr lang="en-IN" sz="1200" dirty="0">
+                          <a:solidFill>
+                            <a:srgbClr val="1F1F1F"/>
+                          </a:solidFill>
+                          <a:effectLst/>
+                        </a:rPr>
+                        <a:t>, S., et al.</a:t>
+                      </a:r>
+                      <a:endParaRPr lang="en-IN" sz="1200" dirty="0">
+                        <a:solidFill>
+                          <a:srgbClr val="1F1F1F"/>
+                        </a:solidFill>
+                        <a:effectLst/>
+                        <a:latin typeface="Google Sans Text"/>
+                      </a:endParaRPr>
+                    </a:p>
+                  </a:txBody>
+                  <a:tcPr marL="15360" marR="15360" marT="20479" marB="20479" anchor="ctr"/>
+                </a:tc>
+                <a:tc>
+                  <a:txBody>
+                    <a:bodyPr/>
+                    <a:lstStyle/>
+                    <a:p>
+                      <a:pPr rtl="0"/>
+                      <a:r>
+                        <a:rPr lang="en-IN" sz="1200">
+                          <a:solidFill>
+                            <a:srgbClr val="1F1F1F"/>
+                          </a:solidFill>
+                          <a:effectLst/>
+                        </a:rPr>
+                        <a:t>Instruction Tuning Limits &amp; Inference Latency (2023)</a:t>
+                      </a:r>
+                      <a:endParaRPr lang="en-IN" sz="1200">
+                        <a:solidFill>
+                          <a:srgbClr val="1F1F1F"/>
+                        </a:solidFill>
+                        <a:effectLst/>
+                        <a:latin typeface="Google Sans Text"/>
+                      </a:endParaRPr>
+                    </a:p>
+                  </a:txBody>
+                  <a:tcPr marL="15360" marR="15360" marT="20479" marB="20479" anchor="ctr"/>
+                </a:tc>
+                <a:tc>
+                  <a:txBody>
+                    <a:bodyPr/>
+                    <a:lstStyle/>
+                    <a:p>
+                      <a:pPr rtl="0"/>
+                      <a:r>
+                        <a:rPr lang="en-US" sz="1200">
+                          <a:solidFill>
+                            <a:srgbClr val="1F1F1F"/>
+                          </a:solidFill>
+                          <a:effectLst/>
+                        </a:rPr>
+                        <a:t>Instruction fine-tuning; Inference latency profiling; Prompt complexity analysis.</a:t>
+                      </a:r>
+                      <a:endParaRPr lang="en-US" sz="1200">
+                        <a:solidFill>
+                          <a:srgbClr val="1F1F1F"/>
+                        </a:solidFill>
+                        <a:effectLst/>
+                        <a:latin typeface="Google Sans Text"/>
+                      </a:endParaRPr>
+                    </a:p>
+                  </a:txBody>
+                  <a:tcPr marL="15360" marR="15360" marT="20479" marB="20479" anchor="ctr"/>
+                </a:tc>
+                <a:tc>
+                  <a:txBody>
+                    <a:bodyPr/>
+                    <a:lstStyle/>
+                    <a:p>
+                      <a:pPr rtl="0"/>
+                      <a:r>
+                        <a:rPr lang="en-US" sz="1200">
+                          <a:solidFill>
+                            <a:srgbClr val="1F1F1F"/>
+                          </a:solidFill>
+                          <a:effectLst/>
+                        </a:rPr>
+                        <a:t>Proved that models perform best when tasks are decoupled; attempting to chat and reason simultaneously drastically degrades speed and accuracy.</a:t>
+                      </a:r>
+                      <a:endParaRPr lang="en-US" sz="1200">
+                        <a:solidFill>
+                          <a:srgbClr val="1F1F1F"/>
+                        </a:solidFill>
+                        <a:effectLst/>
+                        <a:latin typeface="Google Sans Text"/>
+                      </a:endParaRPr>
+                    </a:p>
+                  </a:txBody>
+                  <a:tcPr marL="15360" marR="15360" marT="20479" marB="20479" anchor="ctr"/>
+                </a:tc>
+                <a:tc>
+                  <a:txBody>
+                    <a:bodyPr/>
+                    <a:lstStyle/>
+                    <a:p>
+                      <a:pPr rtl="0"/>
+                      <a:r>
+                        <a:rPr lang="en-US" sz="1200" dirty="0">
+                          <a:solidFill>
+                            <a:srgbClr val="1F1F1F"/>
+                          </a:solidFill>
+                          <a:effectLst/>
+                        </a:rPr>
+                        <a:t>Identified that forcing single-layer LLMs to execute complex reasoning alongside dialogue generation causes unacceptable multi-second delays.</a:t>
+                      </a:r>
+                      <a:endParaRPr lang="en-US" sz="1200" dirty="0">
+                        <a:solidFill>
+                          <a:srgbClr val="1F1F1F"/>
+                        </a:solidFill>
+                        <a:effectLst/>
+                        <a:latin typeface="Google Sans Text"/>
+                      </a:endParaRPr>
+                    </a:p>
+                  </a:txBody>
+                  <a:tcPr marL="15360" marR="15360" marT="20479" marB="20479" anchor="ctr"/>
+                </a:tc>
+                <a:extLst>
+                  <a:ext uri="{0D108BD9-81ED-4DB2-BD59-A6C34878D82A}">
+                    <a16:rowId xmlns:a16="http://schemas.microsoft.com/office/drawing/2014/main" val="429032169"/>
+                  </a:ext>
+                </a:extLst>
+              </a:tr>
+            </a:tbl>
+          </a:graphicData>
+        </a:graphic>
+      </p:graphicFrame>
     </p:spTree>
     <p:extLst>
       <p:ext uri="{BB962C8B-B14F-4D97-AF65-F5344CB8AC3E}">

</xml_diff>